<commit_message>
Defesa: slide do piloto de alocação de missão e revisão das falas
pptx:
- Slide 14 novo (após o Piloto FUUT), no mesmo layout: cenário simples
  (LLM 50/50 no ótimo; despacho fixo até +42%) e cenário com obstáculos
  (fixo até +106%; LLM só com mapa 35/50 no ótimo, pior +54%, mesma
  resposta em 5/10 missões; com distâncias reais 50/50).
- Agenda: item 06 passa a citar os pilotos FUUT e de missão.
- Conclusão: linha nova sobre o piloto de missão (espaçamento ajustado).
  Validado com validate.py; textos conferidos por medida de fonte (sem
  LibreOffice nesta máquina para render).

fala:
- Fala do slide 14 e renumeração 15-18.
- Cada slide marcado com importância (essencial/importante/complementar)
  e tempo-alvo; enxugados Arquitetura, FUUT, Desafios Recentes e Cyclone
  DDS sem mudar números. Total ~18,5 min.

Dados do piloto: branch windows-version, fleet_ws/runs/mission_allocation/.

Co-Authored-By: Claude Opus 5.5 <noreply@anthropic.com>
</commit_message>
<xml_diff>
--- a/disserta-apresenta/apresentacao_defesa.pptx
+++ b/disserta-apresenta/apresentacao_defesa.pptx
@@ -18,6 +18,7 @@
     <p:sldId id="264" r:id="rId11"/>
     <p:sldId id="269" r:id="rId19"/>
     <p:sldId id="271" r:id="rId21"/>
+    <p:sldId id="273" r:id="rId23"/>
     <p:sldId id="265" r:id="rId12"/>
     <p:sldId id="268" r:id="rId13"/>
     <p:sldId id="272" r:id="rId22"/>
@@ -6920,7 +6921,7 @@
         </p:nvSpPr>
         <p:spPr>
           <a:xfrm>
-            <a:off x="6720840" y="1920240"/>
+            <a:off x="6720840" y="1874519"/>
             <a:ext cx="5029200" cy="640080"/>
           </a:xfrm>
           <a:prstGeom prst="rect">
@@ -6955,7 +6956,7 @@
         </p:nvSpPr>
         <p:spPr>
           <a:xfrm>
-            <a:off x="6720840" y="2670048"/>
+            <a:off x="6720840" y="2532887"/>
             <a:ext cx="5029200" cy="640080"/>
           </a:xfrm>
           <a:prstGeom prst="rect">
@@ -6990,7 +6991,7 @@
         </p:nvSpPr>
         <p:spPr>
           <a:xfrm>
-            <a:off x="6720840" y="3419856"/>
+            <a:off x="6720840" y="3191256"/>
             <a:ext cx="5029200" cy="640080"/>
           </a:xfrm>
           <a:prstGeom prst="rect">
@@ -7025,7 +7026,7 @@
         </p:nvSpPr>
         <p:spPr>
           <a:xfrm>
-            <a:off x="6720840" y="4169664"/>
+            <a:off x="6720840" y="3849624"/>
             <a:ext cx="5029200" cy="640080"/>
           </a:xfrm>
           <a:prstGeom prst="rect">
@@ -7054,13 +7055,48 @@
       </p:sp>
       <p:sp>
         <p:nvSpPr>
+          <p:cNvPr id="30" name="TextBox 29"/>
+          <p:cNvSpPr txBox="1"/>
+          <p:nvPr/>
+        </p:nvSpPr>
+        <p:spPr>
+          <a:xfrm>
+            <a:off x="6720840" y="4507992"/>
+            <a:ext cx="5029200" cy="640080"/>
+          </a:xfrm>
+          <a:prstGeom prst="rect">
+            <a:avLst/>
+          </a:prstGeom>
+          <a:noFill/>
+        </p:spPr>
+        <p:txBody>
+          <a:bodyPr wrap="square">
+            <a:spAutoFit/>
+          </a:bodyPr>
+          <a:lstStyle/>
+          <a:p>
+            <a:pPr algn="l"/>
+            <a:r>
+              <a:rPr sz="1500" b="0" i="0">
+                <a:solidFill>
+                  <a:srgbClr val="6EE7B7"/>
+                </a:solidFill>
+                <a:latin typeface="Calibri"/>
+              </a:rPr>
+              <a:t>✓  Missão: LLM interpreta 100%; sem distâncias reais, 35/50 ótimo (pior +54%)</a:t>
+            </a:r>
+          </a:p>
+        </p:txBody>
+      </p:sp>
+      <p:sp>
+        <p:nvSpPr>
           <p:cNvPr id="28" name="TextBox 27"/>
           <p:cNvSpPr txBox="1"/>
           <p:nvPr/>
         </p:nvSpPr>
         <p:spPr>
           <a:xfrm>
-            <a:off x="6720840" y="4919472"/>
+            <a:off x="6720840" y="5166359"/>
             <a:ext cx="5029200" cy="640080"/>
           </a:xfrm>
           <a:prstGeom prst="rect">
@@ -14521,6 +14557,2173 @@
 </p:sld>
 </file>
 
+<file path=ppt/slides/slide18.xml><?xml version="1.0" encoding="utf-8"?>
+<p:sld xmlns:a="http://schemas.openxmlformats.org/drawingml/2006/main" xmlns:r="http://schemas.openxmlformats.org/officeDocument/2006/relationships" xmlns:p="http://schemas.openxmlformats.org/presentationml/2006/main">
+  <p:cSld>
+    <p:spTree>
+      <p:nvGrpSpPr>
+        <p:cNvPr id="1" name=""/>
+        <p:cNvGrpSpPr/>
+        <p:nvPr/>
+      </p:nvGrpSpPr>
+      <p:grpSpPr>
+        <a:xfrm>
+          <a:off x="0" y="0"/>
+          <a:ext cx="0" cy="0"/>
+          <a:chOff x="0" y="0"/>
+          <a:chExt cx="0" cy="0"/>
+        </a:xfrm>
+      </p:grpSpPr>
+      <p:sp>
+        <p:nvSpPr>
+          <p:cNvPr id="2" name="Rectangle 1"/>
+          <p:cNvSpPr/>
+          <p:nvPr/>
+        </p:nvSpPr>
+        <p:spPr>
+          <a:xfrm>
+            <a:off x="0" y="0"/>
+            <a:ext cx="12188952" cy="6858000"/>
+          </a:xfrm>
+          <a:prstGeom prst="rect">
+            <a:avLst/>
+          </a:prstGeom>
+          <a:solidFill>
+            <a:srgbClr val="FFFFFF"/>
+          </a:solidFill>
+          <a:ln>
+            <a:noFill/>
+          </a:ln>
+        </p:spPr>
+        <p:style>
+          <a:lnRef idx="1">
+            <a:schemeClr val="accent1"/>
+          </a:lnRef>
+          <a:fillRef idx="3">
+            <a:schemeClr val="accent1"/>
+          </a:fillRef>
+          <a:effectRef idx="2">
+            <a:schemeClr val="accent1"/>
+          </a:effectRef>
+          <a:fontRef idx="minor">
+            <a:schemeClr val="lt1"/>
+          </a:fontRef>
+        </p:style>
+        <p:txBody>
+          <a:bodyPr rtlCol="0" anchor="ctr"/>
+          <a:lstStyle/>
+          <a:p>
+            <a:pPr algn="ctr"/>
+            <a:endParaRPr/>
+          </a:p>
+        </p:txBody>
+      </p:sp>
+      <p:sp>
+        <p:nvSpPr>
+          <p:cNvPr id="3" name="Rectangle 2"/>
+          <p:cNvSpPr/>
+          <p:nvPr/>
+        </p:nvSpPr>
+        <p:spPr>
+          <a:xfrm>
+            <a:off x="0" y="0"/>
+            <a:ext cx="12188952" cy="1143000"/>
+          </a:xfrm>
+          <a:prstGeom prst="rect">
+            <a:avLst/>
+          </a:prstGeom>
+          <a:solidFill>
+            <a:srgbClr val="1B2A4A"/>
+          </a:solidFill>
+          <a:ln>
+            <a:noFill/>
+          </a:ln>
+        </p:spPr>
+        <p:style>
+          <a:lnRef idx="1">
+            <a:schemeClr val="accent1"/>
+          </a:lnRef>
+          <a:fillRef idx="3">
+            <a:schemeClr val="accent1"/>
+          </a:fillRef>
+          <a:effectRef idx="2">
+            <a:schemeClr val="accent1"/>
+          </a:effectRef>
+          <a:fontRef idx="minor">
+            <a:schemeClr val="lt1"/>
+          </a:fontRef>
+        </p:style>
+        <p:txBody>
+          <a:bodyPr rtlCol="0" anchor="ctr"/>
+          <a:lstStyle/>
+          <a:p>
+            <a:pPr algn="ctr"/>
+            <a:endParaRPr/>
+          </a:p>
+        </p:txBody>
+      </p:sp>
+      <p:sp>
+        <p:nvSpPr>
+          <p:cNvPr id="4" name="Rectangle 3"/>
+          <p:cNvSpPr/>
+          <p:nvPr/>
+        </p:nvSpPr>
+        <p:spPr>
+          <a:xfrm>
+            <a:off x="0" y="1143000"/>
+            <a:ext cx="12188952" cy="45720"/>
+          </a:xfrm>
+          <a:prstGeom prst="rect">
+            <a:avLst/>
+          </a:prstGeom>
+          <a:solidFill>
+            <a:srgbClr val="225AC2"/>
+          </a:solidFill>
+          <a:ln>
+            <a:noFill/>
+          </a:ln>
+        </p:spPr>
+        <p:style>
+          <a:lnRef idx="1">
+            <a:schemeClr val="accent1"/>
+          </a:lnRef>
+          <a:fillRef idx="3">
+            <a:schemeClr val="accent1"/>
+          </a:fillRef>
+          <a:effectRef idx="2">
+            <a:schemeClr val="accent1"/>
+          </a:effectRef>
+          <a:fontRef idx="minor">
+            <a:schemeClr val="lt1"/>
+          </a:fontRef>
+        </p:style>
+        <p:txBody>
+          <a:bodyPr rtlCol="0" anchor="ctr"/>
+          <a:lstStyle/>
+          <a:p>
+            <a:pPr algn="ctr"/>
+            <a:endParaRPr/>
+          </a:p>
+        </p:txBody>
+      </p:sp>
+      <p:sp>
+        <p:nvSpPr>
+          <p:cNvPr id="5" name="TextBox 4"/>
+          <p:cNvSpPr txBox="1"/>
+          <p:nvPr/>
+        </p:nvSpPr>
+        <p:spPr>
+          <a:xfrm>
+            <a:off x="457200" y="137160"/>
+            <a:ext cx="11430000" cy="640080"/>
+          </a:xfrm>
+          <a:prstGeom prst="rect">
+            <a:avLst/>
+          </a:prstGeom>
+          <a:noFill/>
+        </p:spPr>
+        <p:txBody>
+          <a:bodyPr wrap="square">
+            <a:spAutoFit/>
+          </a:bodyPr>
+          <a:lstStyle/>
+          <a:p>
+            <a:pPr algn="l"/>
+            <a:r>
+              <a:rPr sz="3000" b="1" i="0">
+                <a:solidFill>
+                  <a:srgbClr val="FFFFFF"/>
+                </a:solidFill>
+                <a:latin typeface="Calibri"/>
+              </a:rPr>
+              <a:t>Piloto — Alocação de Missão: LLM vs. Ótimo</a:t>
+            </a:r>
+          </a:p>
+        </p:txBody>
+      </p:sp>
+      <p:sp>
+        <p:nvSpPr>
+          <p:cNvPr id="6" name="TextBox 5"/>
+          <p:cNvSpPr txBox="1"/>
+          <p:nvPr/>
+        </p:nvSpPr>
+        <p:spPr>
+          <a:xfrm>
+            <a:off x="457200" y="749808"/>
+            <a:ext cx="11430000" cy="347472"/>
+          </a:xfrm>
+          <a:prstGeom prst="rect">
+            <a:avLst/>
+          </a:prstGeom>
+          <a:noFill/>
+        </p:spPr>
+        <p:txBody>
+          <a:bodyPr wrap="square">
+            <a:spAutoFit/>
+          </a:bodyPr>
+          <a:lstStyle/>
+          <a:p>
+            <a:pPr algn="l"/>
+            <a:r>
+              <a:rPr sz="1400" b="0" i="0">
+                <a:solidFill>
+                  <a:srgbClr val="BFDBFF"/>
+                </a:solidFill>
+                <a:latin typeface="Calibri"/>
+              </a:rPr>
+              <a:t>ACHADO NOVO · 15 missões em linguagem natural · 200 decisões do Claude · sem execução no Gazebo</a:t>
+            </a:r>
+          </a:p>
+        </p:txBody>
+      </p:sp>
+      <p:sp>
+        <p:nvSpPr>
+          <p:cNvPr id="7" name="Rectangle 6"/>
+          <p:cNvSpPr/>
+          <p:nvPr/>
+        </p:nvSpPr>
+        <p:spPr>
+          <a:xfrm>
+            <a:off x="0" y="6537960"/>
+            <a:ext cx="12188952" cy="320040"/>
+          </a:xfrm>
+          <a:prstGeom prst="rect">
+            <a:avLst/>
+          </a:prstGeom>
+          <a:solidFill>
+            <a:srgbClr val="1B2A4A"/>
+          </a:solidFill>
+          <a:ln>
+            <a:noFill/>
+          </a:ln>
+        </p:spPr>
+        <p:style>
+          <a:lnRef idx="1">
+            <a:schemeClr val="accent1"/>
+          </a:lnRef>
+          <a:fillRef idx="3">
+            <a:schemeClr val="accent1"/>
+          </a:fillRef>
+          <a:effectRef idx="2">
+            <a:schemeClr val="accent1"/>
+          </a:effectRef>
+          <a:fontRef idx="minor">
+            <a:schemeClr val="lt1"/>
+          </a:fontRef>
+        </p:style>
+        <p:txBody>
+          <a:bodyPr rtlCol="0" anchor="ctr"/>
+          <a:lstStyle/>
+          <a:p>
+            <a:pPr algn="ctr"/>
+            <a:endParaRPr/>
+          </a:p>
+        </p:txBody>
+      </p:sp>
+      <p:sp>
+        <p:nvSpPr>
+          <p:cNvPr id="8" name="TextBox 7"/>
+          <p:cNvSpPr txBox="1"/>
+          <p:nvPr/>
+        </p:nvSpPr>
+        <p:spPr>
+          <a:xfrm>
+            <a:off x="365760" y="6556248"/>
+            <a:ext cx="7315200" cy="274320"/>
+          </a:xfrm>
+          <a:prstGeom prst="rect">
+            <a:avLst/>
+          </a:prstGeom>
+          <a:noFill/>
+        </p:spPr>
+        <p:txBody>
+          <a:bodyPr wrap="square">
+            <a:spAutoFit/>
+          </a:bodyPr>
+          <a:lstStyle/>
+          <a:p>
+            <a:pPr algn="l"/>
+            <a:r>
+              <a:rPr sz="1100" b="0" i="0">
+                <a:solidFill>
+                  <a:srgbClr val="BFDBFF"/>
+                </a:solidFill>
+                <a:latin typeface="Calibri"/>
+              </a:rPr>
+              <a:t>Defesa de Dissertação · 2026</a:t>
+            </a:r>
+          </a:p>
+        </p:txBody>
+      </p:sp>
+      <p:sp>
+        <p:nvSpPr>
+          <p:cNvPr id="9" name="TextBox 8"/>
+          <p:cNvSpPr txBox="1"/>
+          <p:nvPr/>
+        </p:nvSpPr>
+        <p:spPr>
+          <a:xfrm>
+            <a:off x="8686800" y="6556248"/>
+            <a:ext cx="3200400" cy="274320"/>
+          </a:xfrm>
+          <a:prstGeom prst="rect">
+            <a:avLst/>
+          </a:prstGeom>
+          <a:noFill/>
+        </p:spPr>
+        <p:txBody>
+          <a:bodyPr wrap="square">
+            <a:spAutoFit/>
+          </a:bodyPr>
+          <a:lstStyle/>
+          <a:p>
+            <a:pPr algn="r"/>
+            <a:r>
+              <a:rPr sz="1100" b="0" i="0">
+                <a:solidFill>
+                  <a:srgbClr val="BFDBFF"/>
+                </a:solidFill>
+                <a:latin typeface="Calibri"/>
+              </a:rPr>
+              <a:t>Eduardo Wanderley</a:t>
+            </a:r>
+          </a:p>
+        </p:txBody>
+      </p:sp>
+      <p:sp>
+        <p:nvSpPr>
+          <p:cNvPr id="10" name="TextBox 9"/>
+          <p:cNvSpPr txBox="1"/>
+          <p:nvPr/>
+        </p:nvSpPr>
+        <p:spPr>
+          <a:xfrm>
+            <a:off x="457200" y="1371600"/>
+            <a:ext cx="5486400" cy="347472"/>
+          </a:xfrm>
+          <a:prstGeom prst="rect">
+            <a:avLst/>
+          </a:prstGeom>
+          <a:noFill/>
+        </p:spPr>
+        <p:txBody>
+          <a:bodyPr wrap="square">
+            <a:spAutoFit/>
+          </a:bodyPr>
+          <a:lstStyle/>
+          <a:p>
+            <a:pPr algn="l"/>
+            <a:r>
+              <a:rPr sz="1600" b="1" i="0">
+                <a:solidFill>
+                  <a:srgbClr val="1B2A4A"/>
+                </a:solidFill>
+                <a:latin typeface="Calibri"/>
+              </a:rPr>
+              <a:t>Cenário simples — 5 missões, distância em linha reta</a:t>
+            </a:r>
+          </a:p>
+        </p:txBody>
+      </p:sp>
+      <p:sp>
+        <p:nvSpPr>
+          <p:cNvPr id="11" name="Rectangle 10"/>
+          <p:cNvSpPr/>
+          <p:nvPr/>
+        </p:nvSpPr>
+        <p:spPr>
+          <a:xfrm>
+            <a:off x="457200" y="1755648"/>
+            <a:ext cx="2651760" cy="1143000"/>
+          </a:xfrm>
+          <a:prstGeom prst="rect">
+            <a:avLst/>
+          </a:prstGeom>
+          <a:solidFill>
+            <a:srgbClr val="F3F4F6"/>
+          </a:solidFill>
+          <a:ln>
+            <a:noFill/>
+          </a:ln>
+        </p:spPr>
+        <p:style>
+          <a:lnRef idx="1">
+            <a:schemeClr val="accent1"/>
+          </a:lnRef>
+          <a:fillRef idx="3">
+            <a:schemeClr val="accent1"/>
+          </a:fillRef>
+          <a:effectRef idx="2">
+            <a:schemeClr val="accent1"/>
+          </a:effectRef>
+          <a:fontRef idx="minor">
+            <a:schemeClr val="lt1"/>
+          </a:fontRef>
+        </p:style>
+        <p:txBody>
+          <a:bodyPr rtlCol="0" anchor="ctr"/>
+          <a:lstStyle/>
+          <a:p>
+            <a:pPr algn="ctr"/>
+            <a:endParaRPr/>
+          </a:p>
+        </p:txBody>
+      </p:sp>
+      <p:sp>
+        <p:nvSpPr>
+          <p:cNvPr id="12" name="Rectangle 11"/>
+          <p:cNvSpPr/>
+          <p:nvPr/>
+        </p:nvSpPr>
+        <p:spPr>
+          <a:xfrm>
+            <a:off x="457200" y="1755648"/>
+            <a:ext cx="2651760" cy="54864"/>
+          </a:xfrm>
+          <a:prstGeom prst="rect">
+            <a:avLst/>
+          </a:prstGeom>
+          <a:solidFill>
+            <a:srgbClr val="1B2A4A"/>
+          </a:solidFill>
+          <a:ln>
+            <a:noFill/>
+          </a:ln>
+        </p:spPr>
+        <p:style>
+          <a:lnRef idx="1">
+            <a:schemeClr val="accent1"/>
+          </a:lnRef>
+          <a:fillRef idx="3">
+            <a:schemeClr val="accent1"/>
+          </a:fillRef>
+          <a:effectRef idx="2">
+            <a:schemeClr val="accent1"/>
+          </a:effectRef>
+          <a:fontRef idx="minor">
+            <a:schemeClr val="lt1"/>
+          </a:fontRef>
+        </p:style>
+        <p:txBody>
+          <a:bodyPr rtlCol="0" anchor="ctr"/>
+          <a:lstStyle/>
+          <a:p>
+            <a:pPr algn="ctr"/>
+            <a:endParaRPr/>
+          </a:p>
+        </p:txBody>
+      </p:sp>
+      <p:sp>
+        <p:nvSpPr>
+          <p:cNvPr id="13" name="TextBox 12"/>
+          <p:cNvSpPr txBox="1"/>
+          <p:nvPr/>
+        </p:nvSpPr>
+        <p:spPr>
+          <a:xfrm>
+            <a:off x="594360" y="1847088"/>
+            <a:ext cx="2377440" cy="292608"/>
+          </a:xfrm>
+          <a:prstGeom prst="rect">
+            <a:avLst/>
+          </a:prstGeom>
+          <a:noFill/>
+        </p:spPr>
+        <p:txBody>
+          <a:bodyPr wrap="square">
+            <a:spAutoFit/>
+          </a:bodyPr>
+          <a:lstStyle/>
+          <a:p>
+            <a:pPr algn="l"/>
+            <a:r>
+              <a:rPr sz="1200" b="0" i="0">
+                <a:solidFill>
+                  <a:srgbClr val="6B7280"/>
+                </a:solidFill>
+                <a:latin typeface="Calibri"/>
+              </a:rPr>
+              <a:t>Painel atual (fixo)</a:t>
+            </a:r>
+          </a:p>
+        </p:txBody>
+      </p:sp>
+      <p:sp>
+        <p:nvSpPr>
+          <p:cNvPr id="14" name="TextBox 13"/>
+          <p:cNvSpPr txBox="1"/>
+          <p:nvPr/>
+        </p:nvSpPr>
+        <p:spPr>
+          <a:xfrm>
+            <a:off x="594360" y="2121408"/>
+            <a:ext cx="2377440" cy="457200"/>
+          </a:xfrm>
+          <a:prstGeom prst="rect">
+            <a:avLst/>
+          </a:prstGeom>
+          <a:noFill/>
+        </p:spPr>
+        <p:txBody>
+          <a:bodyPr wrap="square">
+            <a:spAutoFit/>
+          </a:bodyPr>
+          <a:lstStyle/>
+          <a:p>
+            <a:pPr algn="l"/>
+            <a:r>
+              <a:rPr sz="2400" b="1" i="0">
+                <a:solidFill>
+                  <a:srgbClr val="1B2A4A"/>
+                </a:solidFill>
+                <a:latin typeface="Calibri"/>
+              </a:rPr>
+              <a:t>até +42%</a:t>
+            </a:r>
+          </a:p>
+        </p:txBody>
+      </p:sp>
+      <p:sp>
+        <p:nvSpPr>
+          <p:cNvPr id="15" name="TextBox 14"/>
+          <p:cNvSpPr txBox="1"/>
+          <p:nvPr/>
+        </p:nvSpPr>
+        <p:spPr>
+          <a:xfrm>
+            <a:off x="594360" y="2560320"/>
+            <a:ext cx="2377440" cy="228600"/>
+          </a:xfrm>
+          <a:prstGeom prst="rect">
+            <a:avLst/>
+          </a:prstGeom>
+          <a:noFill/>
+        </p:spPr>
+        <p:txBody>
+          <a:bodyPr wrap="square">
+            <a:spAutoFit/>
+          </a:bodyPr>
+          <a:lstStyle/>
+          <a:p>
+            <a:pPr algn="l"/>
+            <a:r>
+              <a:rPr sz="1100" b="0" i="0">
+                <a:solidFill>
+                  <a:srgbClr val="6B7280"/>
+                </a:solidFill>
+                <a:latin typeface="Calibri"/>
+              </a:rPr>
+              <a:t>acima do ótimo</a:t>
+            </a:r>
+          </a:p>
+        </p:txBody>
+      </p:sp>
+      <p:sp>
+        <p:nvSpPr>
+          <p:cNvPr id="16" name="Rectangle 15"/>
+          <p:cNvSpPr/>
+          <p:nvPr/>
+        </p:nvSpPr>
+        <p:spPr>
+          <a:xfrm>
+            <a:off x="3337560" y="1755648"/>
+            <a:ext cx="2651760" cy="1143000"/>
+          </a:xfrm>
+          <a:prstGeom prst="rect">
+            <a:avLst/>
+          </a:prstGeom>
+          <a:solidFill>
+            <a:srgbClr val="F3F4F6"/>
+          </a:solidFill>
+          <a:ln>
+            <a:noFill/>
+          </a:ln>
+        </p:spPr>
+        <p:style>
+          <a:lnRef idx="1">
+            <a:schemeClr val="accent1"/>
+          </a:lnRef>
+          <a:fillRef idx="3">
+            <a:schemeClr val="accent1"/>
+          </a:fillRef>
+          <a:effectRef idx="2">
+            <a:schemeClr val="accent1"/>
+          </a:effectRef>
+          <a:fontRef idx="minor">
+            <a:schemeClr val="lt1"/>
+          </a:fontRef>
+        </p:style>
+        <p:txBody>
+          <a:bodyPr rtlCol="0" anchor="ctr"/>
+          <a:lstStyle/>
+          <a:p>
+            <a:pPr algn="ctr"/>
+            <a:endParaRPr/>
+          </a:p>
+        </p:txBody>
+      </p:sp>
+      <p:sp>
+        <p:nvSpPr>
+          <p:cNvPr id="17" name="Rectangle 16"/>
+          <p:cNvSpPr/>
+          <p:nvPr/>
+        </p:nvSpPr>
+        <p:spPr>
+          <a:xfrm>
+            <a:off x="3337560" y="1755648"/>
+            <a:ext cx="2651760" cy="54864"/>
+          </a:xfrm>
+          <a:prstGeom prst="rect">
+            <a:avLst/>
+          </a:prstGeom>
+          <a:solidFill>
+            <a:srgbClr val="1B2A4A"/>
+          </a:solidFill>
+          <a:ln>
+            <a:noFill/>
+          </a:ln>
+        </p:spPr>
+        <p:style>
+          <a:lnRef idx="1">
+            <a:schemeClr val="accent1"/>
+          </a:lnRef>
+          <a:fillRef idx="3">
+            <a:schemeClr val="accent1"/>
+          </a:fillRef>
+          <a:effectRef idx="2">
+            <a:schemeClr val="accent1"/>
+          </a:effectRef>
+          <a:fontRef idx="minor">
+            <a:schemeClr val="lt1"/>
+          </a:fontRef>
+        </p:style>
+        <p:txBody>
+          <a:bodyPr rtlCol="0" anchor="ctr"/>
+          <a:lstStyle/>
+          <a:p>
+            <a:pPr algn="ctr"/>
+            <a:endParaRPr/>
+          </a:p>
+        </p:txBody>
+      </p:sp>
+      <p:sp>
+        <p:nvSpPr>
+          <p:cNvPr id="18" name="TextBox 17"/>
+          <p:cNvSpPr txBox="1"/>
+          <p:nvPr/>
+        </p:nvSpPr>
+        <p:spPr>
+          <a:xfrm>
+            <a:off x="3474720" y="1847088"/>
+            <a:ext cx="2377440" cy="292608"/>
+          </a:xfrm>
+          <a:prstGeom prst="rect">
+            <a:avLst/>
+          </a:prstGeom>
+          <a:noFill/>
+        </p:spPr>
+        <p:txBody>
+          <a:bodyPr wrap="square">
+            <a:spAutoFit/>
+          </a:bodyPr>
+          <a:lstStyle/>
+          <a:p>
+            <a:pPr algn="l"/>
+            <a:r>
+              <a:rPr sz="1200" b="0" i="0">
+                <a:solidFill>
+                  <a:srgbClr val="6B7280"/>
+                </a:solidFill>
+                <a:latin typeface="Calibri"/>
+              </a:rPr>
+              <a:t>Regra gulosa</a:t>
+            </a:r>
+          </a:p>
+        </p:txBody>
+      </p:sp>
+      <p:sp>
+        <p:nvSpPr>
+          <p:cNvPr id="19" name="TextBox 18"/>
+          <p:cNvSpPr txBox="1"/>
+          <p:nvPr/>
+        </p:nvSpPr>
+        <p:spPr>
+          <a:xfrm>
+            <a:off x="3474720" y="2121408"/>
+            <a:ext cx="2377440" cy="457200"/>
+          </a:xfrm>
+          <a:prstGeom prst="rect">
+            <a:avLst/>
+          </a:prstGeom>
+          <a:noFill/>
+        </p:spPr>
+        <p:txBody>
+          <a:bodyPr wrap="square">
+            <a:spAutoFit/>
+          </a:bodyPr>
+          <a:lstStyle/>
+          <a:p>
+            <a:pPr algn="l"/>
+            <a:r>
+              <a:rPr sz="2400" b="1" i="0">
+                <a:solidFill>
+                  <a:srgbClr val="1B2A4A"/>
+                </a:solidFill>
+                <a:latin typeface="Calibri"/>
+              </a:rPr>
+              <a:t>até +29%</a:t>
+            </a:r>
+          </a:p>
+        </p:txBody>
+      </p:sp>
+      <p:sp>
+        <p:nvSpPr>
+          <p:cNvPr id="20" name="TextBox 19"/>
+          <p:cNvSpPr txBox="1"/>
+          <p:nvPr/>
+        </p:nvSpPr>
+        <p:spPr>
+          <a:xfrm>
+            <a:off x="3474720" y="2560320"/>
+            <a:ext cx="2377440" cy="228600"/>
+          </a:xfrm>
+          <a:prstGeom prst="rect">
+            <a:avLst/>
+          </a:prstGeom>
+          <a:noFill/>
+        </p:spPr>
+        <p:txBody>
+          <a:bodyPr wrap="square">
+            <a:spAutoFit/>
+          </a:bodyPr>
+          <a:lstStyle/>
+          <a:p>
+            <a:pPr algn="l"/>
+            <a:r>
+              <a:rPr sz="1100" b="0" i="0">
+                <a:solidFill>
+                  <a:srgbClr val="6B7280"/>
+                </a:solidFill>
+                <a:latin typeface="Calibri"/>
+              </a:rPr>
+              <a:t>acima do ótimo</a:t>
+            </a:r>
+          </a:p>
+        </p:txBody>
+      </p:sp>
+      <p:sp>
+        <p:nvSpPr>
+          <p:cNvPr id="21" name="Rectangle 20"/>
+          <p:cNvSpPr/>
+          <p:nvPr/>
+        </p:nvSpPr>
+        <p:spPr>
+          <a:xfrm>
+            <a:off x="6217920" y="1755648"/>
+            <a:ext cx="2651760" cy="1143000"/>
+          </a:xfrm>
+          <a:prstGeom prst="rect">
+            <a:avLst/>
+          </a:prstGeom>
+          <a:solidFill>
+            <a:srgbClr val="F3F4F6"/>
+          </a:solidFill>
+          <a:ln>
+            <a:noFill/>
+          </a:ln>
+        </p:spPr>
+        <p:style>
+          <a:lnRef idx="1">
+            <a:schemeClr val="accent1"/>
+          </a:lnRef>
+          <a:fillRef idx="3">
+            <a:schemeClr val="accent1"/>
+          </a:fillRef>
+          <a:effectRef idx="2">
+            <a:schemeClr val="accent1"/>
+          </a:effectRef>
+          <a:fontRef idx="minor">
+            <a:schemeClr val="lt1"/>
+          </a:fontRef>
+        </p:style>
+        <p:txBody>
+          <a:bodyPr rtlCol="0" anchor="ctr"/>
+          <a:lstStyle/>
+          <a:p>
+            <a:pPr algn="ctr"/>
+            <a:endParaRPr/>
+          </a:p>
+        </p:txBody>
+      </p:sp>
+      <p:sp>
+        <p:nvSpPr>
+          <p:cNvPr id="22" name="Rectangle 21"/>
+          <p:cNvSpPr/>
+          <p:nvPr/>
+        </p:nvSpPr>
+        <p:spPr>
+          <a:xfrm>
+            <a:off x="6217920" y="1755648"/>
+            <a:ext cx="2651760" cy="54864"/>
+          </a:xfrm>
+          <a:prstGeom prst="rect">
+            <a:avLst/>
+          </a:prstGeom>
+          <a:solidFill>
+            <a:srgbClr val="1B2A4A"/>
+          </a:solidFill>
+          <a:ln>
+            <a:noFill/>
+          </a:ln>
+        </p:spPr>
+        <p:style>
+          <a:lnRef idx="1">
+            <a:schemeClr val="accent1"/>
+          </a:lnRef>
+          <a:fillRef idx="3">
+            <a:schemeClr val="accent1"/>
+          </a:fillRef>
+          <a:effectRef idx="2">
+            <a:schemeClr val="accent1"/>
+          </a:effectRef>
+          <a:fontRef idx="minor">
+            <a:schemeClr val="lt1"/>
+          </a:fontRef>
+        </p:style>
+        <p:txBody>
+          <a:bodyPr rtlCol="0" anchor="ctr"/>
+          <a:lstStyle/>
+          <a:p>
+            <a:pPr algn="ctr"/>
+            <a:endParaRPr/>
+          </a:p>
+        </p:txBody>
+      </p:sp>
+      <p:sp>
+        <p:nvSpPr>
+          <p:cNvPr id="23" name="TextBox 22"/>
+          <p:cNvSpPr txBox="1"/>
+          <p:nvPr/>
+        </p:nvSpPr>
+        <p:spPr>
+          <a:xfrm>
+            <a:off x="6355080" y="1847088"/>
+            <a:ext cx="2377440" cy="292608"/>
+          </a:xfrm>
+          <a:prstGeom prst="rect">
+            <a:avLst/>
+          </a:prstGeom>
+          <a:noFill/>
+        </p:spPr>
+        <p:txBody>
+          <a:bodyPr wrap="square">
+            <a:spAutoFit/>
+          </a:bodyPr>
+          <a:lstStyle/>
+          <a:p>
+            <a:pPr algn="l"/>
+            <a:r>
+              <a:rPr sz="1200" b="0" i="0">
+                <a:solidFill>
+                  <a:srgbClr val="6B7280"/>
+                </a:solidFill>
+                <a:latin typeface="Calibri"/>
+              </a:rPr>
+              <a:t>LLM (Claude)</a:t>
+            </a:r>
+          </a:p>
+        </p:txBody>
+      </p:sp>
+      <p:sp>
+        <p:nvSpPr>
+          <p:cNvPr id="24" name="TextBox 23"/>
+          <p:cNvSpPr txBox="1"/>
+          <p:nvPr/>
+        </p:nvSpPr>
+        <p:spPr>
+          <a:xfrm>
+            <a:off x="6355080" y="2121408"/>
+            <a:ext cx="2377440" cy="457200"/>
+          </a:xfrm>
+          <a:prstGeom prst="rect">
+            <a:avLst/>
+          </a:prstGeom>
+          <a:noFill/>
+        </p:spPr>
+        <p:txBody>
+          <a:bodyPr wrap="square">
+            <a:spAutoFit/>
+          </a:bodyPr>
+          <a:lstStyle/>
+          <a:p>
+            <a:pPr algn="l"/>
+            <a:r>
+              <a:rPr sz="2400" b="1" i="0">
+                <a:solidFill>
+                  <a:srgbClr val="1B2A4A"/>
+                </a:solidFill>
+                <a:latin typeface="Calibri"/>
+              </a:rPr>
+              <a:t>50/50 ótimo</a:t>
+            </a:r>
+          </a:p>
+        </p:txBody>
+      </p:sp>
+      <p:sp>
+        <p:nvSpPr>
+          <p:cNvPr id="25" name="TextBox 24"/>
+          <p:cNvSpPr txBox="1"/>
+          <p:nvPr/>
+        </p:nvSpPr>
+        <p:spPr>
+          <a:xfrm>
+            <a:off x="6355080" y="2560320"/>
+            <a:ext cx="2377440" cy="228600"/>
+          </a:xfrm>
+          <a:prstGeom prst="rect">
+            <a:avLst/>
+          </a:prstGeom>
+          <a:noFill/>
+        </p:spPr>
+        <p:txBody>
+          <a:bodyPr wrap="square">
+            <a:spAutoFit/>
+          </a:bodyPr>
+          <a:lstStyle/>
+          <a:p>
+            <a:pPr algn="l"/>
+            <a:r>
+              <a:rPr sz="1100" b="0" i="0">
+                <a:solidFill>
+                  <a:srgbClr val="6B7280"/>
+                </a:solidFill>
+                <a:latin typeface="Calibri"/>
+              </a:rPr>
+              <a:t>mesma resposta nas 10 vezes</a:t>
+            </a:r>
+          </a:p>
+        </p:txBody>
+      </p:sp>
+      <p:sp>
+        <p:nvSpPr>
+          <p:cNvPr id="26" name="Rectangle 25"/>
+          <p:cNvSpPr/>
+          <p:nvPr/>
+        </p:nvSpPr>
+        <p:spPr>
+          <a:xfrm>
+            <a:off x="9098280" y="1755648"/>
+            <a:ext cx="2651760" cy="1143000"/>
+          </a:xfrm>
+          <a:prstGeom prst="rect">
+            <a:avLst/>
+          </a:prstGeom>
+          <a:solidFill>
+            <a:srgbClr val="F3F4F6"/>
+          </a:solidFill>
+          <a:ln>
+            <a:noFill/>
+          </a:ln>
+        </p:spPr>
+        <p:style>
+          <a:lnRef idx="1">
+            <a:schemeClr val="accent1"/>
+          </a:lnRef>
+          <a:fillRef idx="3">
+            <a:schemeClr val="accent1"/>
+          </a:fillRef>
+          <a:effectRef idx="2">
+            <a:schemeClr val="accent1"/>
+          </a:effectRef>
+          <a:fontRef idx="minor">
+            <a:schemeClr val="lt1"/>
+          </a:fontRef>
+        </p:style>
+        <p:txBody>
+          <a:bodyPr rtlCol="0" anchor="ctr"/>
+          <a:lstStyle/>
+          <a:p>
+            <a:pPr algn="ctr"/>
+            <a:endParaRPr/>
+          </a:p>
+        </p:txBody>
+      </p:sp>
+      <p:sp>
+        <p:nvSpPr>
+          <p:cNvPr id="27" name="Rectangle 26"/>
+          <p:cNvSpPr/>
+          <p:nvPr/>
+        </p:nvSpPr>
+        <p:spPr>
+          <a:xfrm>
+            <a:off x="9098280" y="1755648"/>
+            <a:ext cx="2651760" cy="54864"/>
+          </a:xfrm>
+          <a:prstGeom prst="rect">
+            <a:avLst/>
+          </a:prstGeom>
+          <a:solidFill>
+            <a:srgbClr val="1B2A4A"/>
+          </a:solidFill>
+          <a:ln>
+            <a:noFill/>
+          </a:ln>
+        </p:spPr>
+        <p:style>
+          <a:lnRef idx="1">
+            <a:schemeClr val="accent1"/>
+          </a:lnRef>
+          <a:fillRef idx="3">
+            <a:schemeClr val="accent1"/>
+          </a:fillRef>
+          <a:effectRef idx="2">
+            <a:schemeClr val="accent1"/>
+          </a:effectRef>
+          <a:fontRef idx="minor">
+            <a:schemeClr val="lt1"/>
+          </a:fontRef>
+        </p:style>
+        <p:txBody>
+          <a:bodyPr rtlCol="0" anchor="ctr"/>
+          <a:lstStyle/>
+          <a:p>
+            <a:pPr algn="ctr"/>
+            <a:endParaRPr/>
+          </a:p>
+        </p:txBody>
+      </p:sp>
+      <p:sp>
+        <p:nvSpPr>
+          <p:cNvPr id="28" name="TextBox 27"/>
+          <p:cNvSpPr txBox="1"/>
+          <p:nvPr/>
+        </p:nvSpPr>
+        <p:spPr>
+          <a:xfrm>
+            <a:off x="9235440" y="1847088"/>
+            <a:ext cx="2377440" cy="292608"/>
+          </a:xfrm>
+          <a:prstGeom prst="rect">
+            <a:avLst/>
+          </a:prstGeom>
+          <a:noFill/>
+        </p:spPr>
+        <p:txBody>
+          <a:bodyPr wrap="square">
+            <a:spAutoFit/>
+          </a:bodyPr>
+          <a:lstStyle/>
+          <a:p>
+            <a:pPr algn="l"/>
+            <a:r>
+              <a:rPr sz="1200" b="0" i="0">
+                <a:solidFill>
+                  <a:srgbClr val="6B7280"/>
+                </a:solidFill>
+                <a:latin typeface="Calibri"/>
+              </a:rPr>
+              <a:t>Latência do LLM</a:t>
+            </a:r>
+          </a:p>
+        </p:txBody>
+      </p:sp>
+      <p:sp>
+        <p:nvSpPr>
+          <p:cNvPr id="29" name="TextBox 28"/>
+          <p:cNvSpPr txBox="1"/>
+          <p:nvPr/>
+        </p:nvSpPr>
+        <p:spPr>
+          <a:xfrm>
+            <a:off x="9235440" y="2121408"/>
+            <a:ext cx="2377440" cy="457200"/>
+          </a:xfrm>
+          <a:prstGeom prst="rect">
+            <a:avLst/>
+          </a:prstGeom>
+          <a:noFill/>
+        </p:spPr>
+        <p:txBody>
+          <a:bodyPr wrap="square">
+            <a:spAutoFit/>
+          </a:bodyPr>
+          <a:lstStyle/>
+          <a:p>
+            <a:pPr algn="l"/>
+            <a:r>
+              <a:rPr sz="2400" b="1" i="0">
+                <a:solidFill>
+                  <a:srgbClr val="1B2A4A"/>
+                </a:solidFill>
+                <a:latin typeface="Calibri"/>
+              </a:rPr>
+              <a:t>7 → 26 s</a:t>
+            </a:r>
+          </a:p>
+        </p:txBody>
+      </p:sp>
+      <p:sp>
+        <p:nvSpPr>
+          <p:cNvPr id="30" name="TextBox 29"/>
+          <p:cNvSpPr txBox="1"/>
+          <p:nvPr/>
+        </p:nvSpPr>
+        <p:spPr>
+          <a:xfrm>
+            <a:off x="9235440" y="2560320"/>
+            <a:ext cx="2377440" cy="228600"/>
+          </a:xfrm>
+          <a:prstGeom prst="rect">
+            <a:avLst/>
+          </a:prstGeom>
+          <a:noFill/>
+        </p:spPr>
+        <p:txBody>
+          <a:bodyPr wrap="square">
+            <a:spAutoFit/>
+          </a:bodyPr>
+          <a:lstStyle/>
+          <a:p>
+            <a:pPr algn="l"/>
+            <a:r>
+              <a:rPr sz="1100" b="0" i="0">
+                <a:solidFill>
+                  <a:srgbClr val="6B7280"/>
+                </a:solidFill>
+                <a:latin typeface="Calibri"/>
+              </a:rPr>
+              <a:t>solver exato: milissegundos</a:t>
+            </a:r>
+          </a:p>
+        </p:txBody>
+      </p:sp>
+      <p:sp>
+        <p:nvSpPr>
+          <p:cNvPr id="31" name="TextBox 30"/>
+          <p:cNvSpPr txBox="1"/>
+          <p:nvPr/>
+        </p:nvSpPr>
+        <p:spPr>
+          <a:xfrm>
+            <a:off x="457200" y="3090672"/>
+            <a:ext cx="5486400" cy="347472"/>
+          </a:xfrm>
+          <a:prstGeom prst="rect">
+            <a:avLst/>
+          </a:prstGeom>
+          <a:noFill/>
+        </p:spPr>
+        <p:txBody>
+          <a:bodyPr wrap="square">
+            <a:spAutoFit/>
+          </a:bodyPr>
+          <a:lstStyle/>
+          <a:p>
+            <a:pPr algn="l"/>
+            <a:r>
+              <a:rPr sz="1600" b="1" i="0">
+                <a:solidFill>
+                  <a:srgbClr val="059669"/>
+                </a:solidFill>
+                <a:latin typeface="Calibri"/>
+              </a:rPr>
+              <a:t>Com obstáculos — 10 missões, caminho real no mapa</a:t>
+            </a:r>
+          </a:p>
+        </p:txBody>
+      </p:sp>
+      <p:sp>
+        <p:nvSpPr>
+          <p:cNvPr id="32" name="Rectangle 31"/>
+          <p:cNvSpPr/>
+          <p:nvPr/>
+        </p:nvSpPr>
+        <p:spPr>
+          <a:xfrm>
+            <a:off x="457200" y="3456432"/>
+            <a:ext cx="2651760" cy="1143000"/>
+          </a:xfrm>
+          <a:prstGeom prst="rect">
+            <a:avLst/>
+          </a:prstGeom>
+          <a:solidFill>
+            <a:srgbClr val="F3F4F6"/>
+          </a:solidFill>
+          <a:ln>
+            <a:noFill/>
+          </a:ln>
+        </p:spPr>
+        <p:style>
+          <a:lnRef idx="1">
+            <a:schemeClr val="accent1"/>
+          </a:lnRef>
+          <a:fillRef idx="3">
+            <a:schemeClr val="accent1"/>
+          </a:fillRef>
+          <a:effectRef idx="2">
+            <a:schemeClr val="accent1"/>
+          </a:effectRef>
+          <a:fontRef idx="minor">
+            <a:schemeClr val="lt1"/>
+          </a:fontRef>
+        </p:style>
+        <p:txBody>
+          <a:bodyPr rtlCol="0" anchor="ctr"/>
+          <a:lstStyle/>
+          <a:p>
+            <a:pPr algn="ctr"/>
+            <a:endParaRPr/>
+          </a:p>
+        </p:txBody>
+      </p:sp>
+      <p:sp>
+        <p:nvSpPr>
+          <p:cNvPr id="33" name="Rectangle 32"/>
+          <p:cNvSpPr/>
+          <p:nvPr/>
+        </p:nvSpPr>
+        <p:spPr>
+          <a:xfrm>
+            <a:off x="457200" y="3456432"/>
+            <a:ext cx="2651760" cy="54864"/>
+          </a:xfrm>
+          <a:prstGeom prst="rect">
+            <a:avLst/>
+          </a:prstGeom>
+          <a:solidFill>
+            <a:srgbClr val="059669"/>
+          </a:solidFill>
+          <a:ln>
+            <a:noFill/>
+          </a:ln>
+        </p:spPr>
+        <p:style>
+          <a:lnRef idx="1">
+            <a:schemeClr val="accent1"/>
+          </a:lnRef>
+          <a:fillRef idx="3">
+            <a:schemeClr val="accent1"/>
+          </a:fillRef>
+          <a:effectRef idx="2">
+            <a:schemeClr val="accent1"/>
+          </a:effectRef>
+          <a:fontRef idx="minor">
+            <a:schemeClr val="lt1"/>
+          </a:fontRef>
+        </p:style>
+        <p:txBody>
+          <a:bodyPr rtlCol="0" anchor="ctr"/>
+          <a:lstStyle/>
+          <a:p>
+            <a:pPr algn="ctr"/>
+            <a:endParaRPr/>
+          </a:p>
+        </p:txBody>
+      </p:sp>
+      <p:sp>
+        <p:nvSpPr>
+          <p:cNvPr id="34" name="TextBox 33"/>
+          <p:cNvSpPr txBox="1"/>
+          <p:nvPr/>
+        </p:nvSpPr>
+        <p:spPr>
+          <a:xfrm>
+            <a:off x="594360" y="3547872"/>
+            <a:ext cx="2377440" cy="292608"/>
+          </a:xfrm>
+          <a:prstGeom prst="rect">
+            <a:avLst/>
+          </a:prstGeom>
+          <a:noFill/>
+        </p:spPr>
+        <p:txBody>
+          <a:bodyPr wrap="square">
+            <a:spAutoFit/>
+          </a:bodyPr>
+          <a:lstStyle/>
+          <a:p>
+            <a:pPr algn="l"/>
+            <a:r>
+              <a:rPr sz="1200" b="0" i="0">
+                <a:solidFill>
+                  <a:srgbClr val="6B7280"/>
+                </a:solidFill>
+                <a:latin typeface="Calibri"/>
+              </a:rPr>
+              <a:t>Painel atual (fixo)</a:t>
+            </a:r>
+          </a:p>
+        </p:txBody>
+      </p:sp>
+      <p:sp>
+        <p:nvSpPr>
+          <p:cNvPr id="35" name="TextBox 34"/>
+          <p:cNvSpPr txBox="1"/>
+          <p:nvPr/>
+        </p:nvSpPr>
+        <p:spPr>
+          <a:xfrm>
+            <a:off x="594360" y="3822192"/>
+            <a:ext cx="2377440" cy="457200"/>
+          </a:xfrm>
+          <a:prstGeom prst="rect">
+            <a:avLst/>
+          </a:prstGeom>
+          <a:noFill/>
+        </p:spPr>
+        <p:txBody>
+          <a:bodyPr wrap="square">
+            <a:spAutoFit/>
+          </a:bodyPr>
+          <a:lstStyle/>
+          <a:p>
+            <a:pPr algn="l"/>
+            <a:r>
+              <a:rPr sz="2400" b="1" i="0">
+                <a:solidFill>
+                  <a:srgbClr val="059669"/>
+                </a:solidFill>
+                <a:latin typeface="Calibri"/>
+              </a:rPr>
+              <a:t>até +106%</a:t>
+            </a:r>
+          </a:p>
+        </p:txBody>
+      </p:sp>
+      <p:sp>
+        <p:nvSpPr>
+          <p:cNvPr id="36" name="TextBox 35"/>
+          <p:cNvSpPr txBox="1"/>
+          <p:nvPr/>
+        </p:nvSpPr>
+        <p:spPr>
+          <a:xfrm>
+            <a:off x="594360" y="4261104"/>
+            <a:ext cx="2377440" cy="228600"/>
+          </a:xfrm>
+          <a:prstGeom prst="rect">
+            <a:avLst/>
+          </a:prstGeom>
+          <a:noFill/>
+        </p:spPr>
+        <p:txBody>
+          <a:bodyPr wrap="square">
+            <a:spAutoFit/>
+          </a:bodyPr>
+          <a:lstStyle/>
+          <a:p>
+            <a:pPr algn="l"/>
+            <a:r>
+              <a:rPr sz="1100" b="0" i="0">
+                <a:solidFill>
+                  <a:srgbClr val="6B7280"/>
+                </a:solidFill>
+                <a:latin typeface="Calibri"/>
+              </a:rPr>
+              <a:t>acima do ótimo</a:t>
+            </a:r>
+          </a:p>
+        </p:txBody>
+      </p:sp>
+      <p:sp>
+        <p:nvSpPr>
+          <p:cNvPr id="37" name="Rectangle 36"/>
+          <p:cNvSpPr/>
+          <p:nvPr/>
+        </p:nvSpPr>
+        <p:spPr>
+          <a:xfrm>
+            <a:off x="3337560" y="3456432"/>
+            <a:ext cx="2651760" cy="1143000"/>
+          </a:xfrm>
+          <a:prstGeom prst="rect">
+            <a:avLst/>
+          </a:prstGeom>
+          <a:solidFill>
+            <a:srgbClr val="F3F4F6"/>
+          </a:solidFill>
+          <a:ln>
+            <a:noFill/>
+          </a:ln>
+        </p:spPr>
+        <p:style>
+          <a:lnRef idx="1">
+            <a:schemeClr val="accent1"/>
+          </a:lnRef>
+          <a:fillRef idx="3">
+            <a:schemeClr val="accent1"/>
+          </a:fillRef>
+          <a:effectRef idx="2">
+            <a:schemeClr val="accent1"/>
+          </a:effectRef>
+          <a:fontRef idx="minor">
+            <a:schemeClr val="lt1"/>
+          </a:fontRef>
+        </p:style>
+        <p:txBody>
+          <a:bodyPr rtlCol="0" anchor="ctr"/>
+          <a:lstStyle/>
+          <a:p>
+            <a:pPr algn="ctr"/>
+            <a:endParaRPr/>
+          </a:p>
+        </p:txBody>
+      </p:sp>
+      <p:sp>
+        <p:nvSpPr>
+          <p:cNvPr id="38" name="Rectangle 37"/>
+          <p:cNvSpPr/>
+          <p:nvPr/>
+        </p:nvSpPr>
+        <p:spPr>
+          <a:xfrm>
+            <a:off x="3337560" y="3456432"/>
+            <a:ext cx="2651760" cy="54864"/>
+          </a:xfrm>
+          <a:prstGeom prst="rect">
+            <a:avLst/>
+          </a:prstGeom>
+          <a:solidFill>
+            <a:srgbClr val="059669"/>
+          </a:solidFill>
+          <a:ln>
+            <a:noFill/>
+          </a:ln>
+        </p:spPr>
+        <p:style>
+          <a:lnRef idx="1">
+            <a:schemeClr val="accent1"/>
+          </a:lnRef>
+          <a:fillRef idx="3">
+            <a:schemeClr val="accent1"/>
+          </a:fillRef>
+          <a:effectRef idx="2">
+            <a:schemeClr val="accent1"/>
+          </a:effectRef>
+          <a:fontRef idx="minor">
+            <a:schemeClr val="lt1"/>
+          </a:fontRef>
+        </p:style>
+        <p:txBody>
+          <a:bodyPr rtlCol="0" anchor="ctr"/>
+          <a:lstStyle/>
+          <a:p>
+            <a:pPr algn="ctr"/>
+            <a:endParaRPr/>
+          </a:p>
+        </p:txBody>
+      </p:sp>
+      <p:sp>
+        <p:nvSpPr>
+          <p:cNvPr id="39" name="TextBox 38"/>
+          <p:cNvSpPr txBox="1"/>
+          <p:nvPr/>
+        </p:nvSpPr>
+        <p:spPr>
+          <a:xfrm>
+            <a:off x="3474720" y="3547872"/>
+            <a:ext cx="2377440" cy="292608"/>
+          </a:xfrm>
+          <a:prstGeom prst="rect">
+            <a:avLst/>
+          </a:prstGeom>
+          <a:noFill/>
+        </p:spPr>
+        <p:txBody>
+          <a:bodyPr wrap="square">
+            <a:spAutoFit/>
+          </a:bodyPr>
+          <a:lstStyle/>
+          <a:p>
+            <a:pPr algn="l"/>
+            <a:r>
+              <a:rPr sz="1200" b="0" i="0">
+                <a:solidFill>
+                  <a:srgbClr val="6B7280"/>
+                </a:solidFill>
+                <a:latin typeface="Calibri"/>
+              </a:rPr>
+              <a:t>LLM só com o mapa</a:t>
+            </a:r>
+          </a:p>
+        </p:txBody>
+      </p:sp>
+      <p:sp>
+        <p:nvSpPr>
+          <p:cNvPr id="40" name="TextBox 39"/>
+          <p:cNvSpPr txBox="1"/>
+          <p:nvPr/>
+        </p:nvSpPr>
+        <p:spPr>
+          <a:xfrm>
+            <a:off x="3474720" y="3822192"/>
+            <a:ext cx="2377440" cy="457200"/>
+          </a:xfrm>
+          <a:prstGeom prst="rect">
+            <a:avLst/>
+          </a:prstGeom>
+          <a:noFill/>
+        </p:spPr>
+        <p:txBody>
+          <a:bodyPr wrap="square">
+            <a:spAutoFit/>
+          </a:bodyPr>
+          <a:lstStyle/>
+          <a:p>
+            <a:pPr algn="l"/>
+            <a:r>
+              <a:rPr sz="2400" b="1" i="0">
+                <a:solidFill>
+                  <a:srgbClr val="059669"/>
+                </a:solidFill>
+                <a:latin typeface="Calibri"/>
+              </a:rPr>
+              <a:t>35/50 ótimo</a:t>
+            </a:r>
+          </a:p>
+        </p:txBody>
+      </p:sp>
+      <p:sp>
+        <p:nvSpPr>
+          <p:cNvPr id="41" name="TextBox 40"/>
+          <p:cNvSpPr txBox="1"/>
+          <p:nvPr/>
+        </p:nvSpPr>
+        <p:spPr>
+          <a:xfrm>
+            <a:off x="3474720" y="4261104"/>
+            <a:ext cx="2377440" cy="228600"/>
+          </a:xfrm>
+          <a:prstGeom prst="rect">
+            <a:avLst/>
+          </a:prstGeom>
+          <a:noFill/>
+        </p:spPr>
+        <p:txBody>
+          <a:bodyPr wrap="square">
+            <a:spAutoFit/>
+          </a:bodyPr>
+          <a:lstStyle/>
+          <a:p>
+            <a:pPr algn="l"/>
+            <a:r>
+              <a:rPr sz="1100" b="0" i="0">
+                <a:solidFill>
+                  <a:srgbClr val="6B7280"/>
+                </a:solidFill>
+                <a:latin typeface="Calibri"/>
+              </a:rPr>
+              <a:t>pior caso +54% (armadilhas)</a:t>
+            </a:r>
+          </a:p>
+        </p:txBody>
+      </p:sp>
+      <p:sp>
+        <p:nvSpPr>
+          <p:cNvPr id="42" name="Rectangle 41"/>
+          <p:cNvSpPr/>
+          <p:nvPr/>
+        </p:nvSpPr>
+        <p:spPr>
+          <a:xfrm>
+            <a:off x="6217920" y="3456432"/>
+            <a:ext cx="2651760" cy="1143000"/>
+          </a:xfrm>
+          <a:prstGeom prst="rect">
+            <a:avLst/>
+          </a:prstGeom>
+          <a:solidFill>
+            <a:srgbClr val="F3F4F6"/>
+          </a:solidFill>
+          <a:ln>
+            <a:noFill/>
+          </a:ln>
+        </p:spPr>
+        <p:style>
+          <a:lnRef idx="1">
+            <a:schemeClr val="accent1"/>
+          </a:lnRef>
+          <a:fillRef idx="3">
+            <a:schemeClr val="accent1"/>
+          </a:fillRef>
+          <a:effectRef idx="2">
+            <a:schemeClr val="accent1"/>
+          </a:effectRef>
+          <a:fontRef idx="minor">
+            <a:schemeClr val="lt1"/>
+          </a:fontRef>
+        </p:style>
+        <p:txBody>
+          <a:bodyPr rtlCol="0" anchor="ctr"/>
+          <a:lstStyle/>
+          <a:p>
+            <a:pPr algn="ctr"/>
+            <a:endParaRPr/>
+          </a:p>
+        </p:txBody>
+      </p:sp>
+      <p:sp>
+        <p:nvSpPr>
+          <p:cNvPr id="43" name="Rectangle 42"/>
+          <p:cNvSpPr/>
+          <p:nvPr/>
+        </p:nvSpPr>
+        <p:spPr>
+          <a:xfrm>
+            <a:off x="6217920" y="3456432"/>
+            <a:ext cx="2651760" cy="54864"/>
+          </a:xfrm>
+          <a:prstGeom prst="rect">
+            <a:avLst/>
+          </a:prstGeom>
+          <a:solidFill>
+            <a:srgbClr val="059669"/>
+          </a:solidFill>
+          <a:ln>
+            <a:noFill/>
+          </a:ln>
+        </p:spPr>
+        <p:style>
+          <a:lnRef idx="1">
+            <a:schemeClr val="accent1"/>
+          </a:lnRef>
+          <a:fillRef idx="3">
+            <a:schemeClr val="accent1"/>
+          </a:fillRef>
+          <a:effectRef idx="2">
+            <a:schemeClr val="accent1"/>
+          </a:effectRef>
+          <a:fontRef idx="minor">
+            <a:schemeClr val="lt1"/>
+          </a:fontRef>
+        </p:style>
+        <p:txBody>
+          <a:bodyPr rtlCol="0" anchor="ctr"/>
+          <a:lstStyle/>
+          <a:p>
+            <a:pPr algn="ctr"/>
+            <a:endParaRPr/>
+          </a:p>
+        </p:txBody>
+      </p:sp>
+      <p:sp>
+        <p:nvSpPr>
+          <p:cNvPr id="44" name="TextBox 43"/>
+          <p:cNvSpPr txBox="1"/>
+          <p:nvPr/>
+        </p:nvSpPr>
+        <p:spPr>
+          <a:xfrm>
+            <a:off x="6355080" y="3547872"/>
+            <a:ext cx="2377440" cy="292608"/>
+          </a:xfrm>
+          <a:prstGeom prst="rect">
+            <a:avLst/>
+          </a:prstGeom>
+          <a:noFill/>
+        </p:spPr>
+        <p:txBody>
+          <a:bodyPr wrap="square">
+            <a:spAutoFit/>
+          </a:bodyPr>
+          <a:lstStyle/>
+          <a:p>
+            <a:pPr algn="l"/>
+            <a:r>
+              <a:rPr sz="1200" b="0" i="0">
+                <a:solidFill>
+                  <a:srgbClr val="6B7280"/>
+                </a:solidFill>
+                <a:latin typeface="Calibri"/>
+              </a:rPr>
+              <a:t>Repetibilidade do LLM</a:t>
+            </a:r>
+          </a:p>
+        </p:txBody>
+      </p:sp>
+      <p:sp>
+        <p:nvSpPr>
+          <p:cNvPr id="45" name="TextBox 44"/>
+          <p:cNvSpPr txBox="1"/>
+          <p:nvPr/>
+        </p:nvSpPr>
+        <p:spPr>
+          <a:xfrm>
+            <a:off x="6355080" y="3822192"/>
+            <a:ext cx="2377440" cy="457200"/>
+          </a:xfrm>
+          <a:prstGeom prst="rect">
+            <a:avLst/>
+          </a:prstGeom>
+          <a:noFill/>
+        </p:spPr>
+        <p:txBody>
+          <a:bodyPr wrap="square">
+            <a:spAutoFit/>
+          </a:bodyPr>
+          <a:lstStyle/>
+          <a:p>
+            <a:pPr algn="l"/>
+            <a:r>
+              <a:rPr sz="2400" b="1" i="0">
+                <a:solidFill>
+                  <a:srgbClr val="059669"/>
+                </a:solidFill>
+                <a:latin typeface="Calibri"/>
+              </a:rPr>
+              <a:t>5/10 missões</a:t>
+            </a:r>
+          </a:p>
+        </p:txBody>
+      </p:sp>
+      <p:sp>
+        <p:nvSpPr>
+          <p:cNvPr id="46" name="TextBox 45"/>
+          <p:cNvSpPr txBox="1"/>
+          <p:nvPr/>
+        </p:nvSpPr>
+        <p:spPr>
+          <a:xfrm>
+            <a:off x="6355080" y="4261104"/>
+            <a:ext cx="2377440" cy="228600"/>
+          </a:xfrm>
+          <a:prstGeom prst="rect">
+            <a:avLst/>
+          </a:prstGeom>
+          <a:noFill/>
+        </p:spPr>
+        <p:txBody>
+          <a:bodyPr wrap="square">
+            <a:spAutoFit/>
+          </a:bodyPr>
+          <a:lstStyle/>
+          <a:p>
+            <a:pPr algn="l"/>
+            <a:r>
+              <a:rPr sz="1100" b="0" i="0">
+                <a:solidFill>
+                  <a:srgbClr val="6B7280"/>
+                </a:solidFill>
+                <a:latin typeface="Calibri"/>
+              </a:rPr>
+              <a:t>com a mesma resposta sempre</a:t>
+            </a:r>
+          </a:p>
+        </p:txBody>
+      </p:sp>
+      <p:sp>
+        <p:nvSpPr>
+          <p:cNvPr id="47" name="Rectangle 46"/>
+          <p:cNvSpPr/>
+          <p:nvPr/>
+        </p:nvSpPr>
+        <p:spPr>
+          <a:xfrm>
+            <a:off x="9098280" y="3456432"/>
+            <a:ext cx="2651760" cy="1143000"/>
+          </a:xfrm>
+          <a:prstGeom prst="rect">
+            <a:avLst/>
+          </a:prstGeom>
+          <a:solidFill>
+            <a:srgbClr val="F3F4F6"/>
+          </a:solidFill>
+          <a:ln>
+            <a:noFill/>
+          </a:ln>
+        </p:spPr>
+        <p:style>
+          <a:lnRef idx="1">
+            <a:schemeClr val="accent1"/>
+          </a:lnRef>
+          <a:fillRef idx="3">
+            <a:schemeClr val="accent1"/>
+          </a:fillRef>
+          <a:effectRef idx="2">
+            <a:schemeClr val="accent1"/>
+          </a:effectRef>
+          <a:fontRef idx="minor">
+            <a:schemeClr val="lt1"/>
+          </a:fontRef>
+        </p:style>
+        <p:txBody>
+          <a:bodyPr rtlCol="0" anchor="ctr"/>
+          <a:lstStyle/>
+          <a:p>
+            <a:pPr algn="ctr"/>
+            <a:endParaRPr/>
+          </a:p>
+        </p:txBody>
+      </p:sp>
+      <p:sp>
+        <p:nvSpPr>
+          <p:cNvPr id="48" name="Rectangle 47"/>
+          <p:cNvSpPr/>
+          <p:nvPr/>
+        </p:nvSpPr>
+        <p:spPr>
+          <a:xfrm>
+            <a:off x="9098280" y="3456432"/>
+            <a:ext cx="2651760" cy="54864"/>
+          </a:xfrm>
+          <a:prstGeom prst="rect">
+            <a:avLst/>
+          </a:prstGeom>
+          <a:solidFill>
+            <a:srgbClr val="059669"/>
+          </a:solidFill>
+          <a:ln>
+            <a:noFill/>
+          </a:ln>
+        </p:spPr>
+        <p:style>
+          <a:lnRef idx="1">
+            <a:schemeClr val="accent1"/>
+          </a:lnRef>
+          <a:fillRef idx="3">
+            <a:schemeClr val="accent1"/>
+          </a:fillRef>
+          <a:effectRef idx="2">
+            <a:schemeClr val="accent1"/>
+          </a:effectRef>
+          <a:fontRef idx="minor">
+            <a:schemeClr val="lt1"/>
+          </a:fontRef>
+        </p:style>
+        <p:txBody>
+          <a:bodyPr rtlCol="0" anchor="ctr"/>
+          <a:lstStyle/>
+          <a:p>
+            <a:pPr algn="ctr"/>
+            <a:endParaRPr/>
+          </a:p>
+        </p:txBody>
+      </p:sp>
+      <p:sp>
+        <p:nvSpPr>
+          <p:cNvPr id="49" name="TextBox 48"/>
+          <p:cNvSpPr txBox="1"/>
+          <p:nvPr/>
+        </p:nvSpPr>
+        <p:spPr>
+          <a:xfrm>
+            <a:off x="9235440" y="3547872"/>
+            <a:ext cx="2377440" cy="292608"/>
+          </a:xfrm>
+          <a:prstGeom prst="rect">
+            <a:avLst/>
+          </a:prstGeom>
+          <a:noFill/>
+        </p:spPr>
+        <p:txBody>
+          <a:bodyPr wrap="square">
+            <a:spAutoFit/>
+          </a:bodyPr>
+          <a:lstStyle/>
+          <a:p>
+            <a:pPr algn="l"/>
+            <a:r>
+              <a:rPr sz="1200" b="0" i="0">
+                <a:solidFill>
+                  <a:srgbClr val="6B7280"/>
+                </a:solidFill>
+                <a:latin typeface="Calibri"/>
+              </a:rPr>
+              <a:t>LLM + distâncias reais</a:t>
+            </a:r>
+          </a:p>
+        </p:txBody>
+      </p:sp>
+      <p:sp>
+        <p:nvSpPr>
+          <p:cNvPr id="50" name="TextBox 49"/>
+          <p:cNvSpPr txBox="1"/>
+          <p:nvPr/>
+        </p:nvSpPr>
+        <p:spPr>
+          <a:xfrm>
+            <a:off x="9235440" y="3822192"/>
+            <a:ext cx="2377440" cy="457200"/>
+          </a:xfrm>
+          <a:prstGeom prst="rect">
+            <a:avLst/>
+          </a:prstGeom>
+          <a:noFill/>
+        </p:spPr>
+        <p:txBody>
+          <a:bodyPr wrap="square">
+            <a:spAutoFit/>
+          </a:bodyPr>
+          <a:lstStyle/>
+          <a:p>
+            <a:pPr algn="l"/>
+            <a:r>
+              <a:rPr sz="2400" b="1" i="0">
+                <a:solidFill>
+                  <a:srgbClr val="059669"/>
+                </a:solidFill>
+                <a:latin typeface="Calibri"/>
+              </a:rPr>
+              <a:t>50/50 ótimo</a:t>
+            </a:r>
+          </a:p>
+        </p:txBody>
+      </p:sp>
+      <p:sp>
+        <p:nvSpPr>
+          <p:cNvPr id="51" name="TextBox 50"/>
+          <p:cNvSpPr txBox="1"/>
+          <p:nvPr/>
+        </p:nvSpPr>
+        <p:spPr>
+          <a:xfrm>
+            <a:off x="9235440" y="4261104"/>
+            <a:ext cx="2377440" cy="228600"/>
+          </a:xfrm>
+          <a:prstGeom prst="rect">
+            <a:avLst/>
+          </a:prstGeom>
+          <a:noFill/>
+        </p:spPr>
+        <p:txBody>
+          <a:bodyPr wrap="square">
+            <a:spAutoFit/>
+          </a:bodyPr>
+          <a:lstStyle/>
+          <a:p>
+            <a:pPr algn="l"/>
+            <a:r>
+              <a:rPr sz="1100" b="0" i="0">
+                <a:solidFill>
+                  <a:srgbClr val="6B7280"/>
+                </a:solidFill>
+                <a:latin typeface="Calibri"/>
+              </a:rPr>
+              <a:t>e repetível</a:t>
+            </a:r>
+          </a:p>
+        </p:txBody>
+      </p:sp>
+      <p:sp>
+        <p:nvSpPr>
+          <p:cNvPr id="52" name="Rectangle 51"/>
+          <p:cNvSpPr/>
+          <p:nvPr/>
+        </p:nvSpPr>
+        <p:spPr>
+          <a:xfrm>
+            <a:off x="457200" y="4754880"/>
+            <a:ext cx="11274552" cy="914400"/>
+          </a:xfrm>
+          <a:prstGeom prst="rect">
+            <a:avLst/>
+          </a:prstGeom>
+          <a:solidFill>
+            <a:srgbClr val="F3F4F6"/>
+          </a:solidFill>
+          <a:ln>
+            <a:noFill/>
+          </a:ln>
+        </p:spPr>
+        <p:style>
+          <a:lnRef idx="1">
+            <a:schemeClr val="accent1"/>
+          </a:lnRef>
+          <a:fillRef idx="3">
+            <a:schemeClr val="accent1"/>
+          </a:fillRef>
+          <a:effectRef idx="2">
+            <a:schemeClr val="accent1"/>
+          </a:effectRef>
+          <a:fontRef idx="minor">
+            <a:schemeClr val="lt1"/>
+          </a:fontRef>
+        </p:style>
+        <p:txBody>
+          <a:bodyPr rtlCol="0" anchor="ctr"/>
+          <a:lstStyle/>
+          <a:p>
+            <a:pPr algn="ctr"/>
+            <a:endParaRPr/>
+          </a:p>
+        </p:txBody>
+      </p:sp>
+      <p:sp>
+        <p:nvSpPr>
+          <p:cNvPr id="53" name="Rectangle 52"/>
+          <p:cNvSpPr/>
+          <p:nvPr/>
+        </p:nvSpPr>
+        <p:spPr>
+          <a:xfrm>
+            <a:off x="457200" y="4754880"/>
+            <a:ext cx="91440" cy="914400"/>
+          </a:xfrm>
+          <a:prstGeom prst="rect">
+            <a:avLst/>
+          </a:prstGeom>
+          <a:solidFill>
+            <a:srgbClr val="059669"/>
+          </a:solidFill>
+          <a:ln>
+            <a:noFill/>
+          </a:ln>
+        </p:spPr>
+        <p:style>
+          <a:lnRef idx="1">
+            <a:schemeClr val="accent1"/>
+          </a:lnRef>
+          <a:fillRef idx="3">
+            <a:schemeClr val="accent1"/>
+          </a:fillRef>
+          <a:effectRef idx="2">
+            <a:schemeClr val="accent1"/>
+          </a:effectRef>
+          <a:fontRef idx="minor">
+            <a:schemeClr val="lt1"/>
+          </a:fontRef>
+        </p:style>
+        <p:txBody>
+          <a:bodyPr rtlCol="0" anchor="ctr"/>
+          <a:lstStyle/>
+          <a:p>
+            <a:pPr algn="ctr"/>
+            <a:endParaRPr/>
+          </a:p>
+        </p:txBody>
+      </p:sp>
+      <p:sp>
+        <p:nvSpPr>
+          <p:cNvPr id="54" name="TextBox 53"/>
+          <p:cNvSpPr txBox="1"/>
+          <p:nvPr/>
+        </p:nvSpPr>
+        <p:spPr>
+          <a:xfrm>
+            <a:off x="685800" y="4828032"/>
+            <a:ext cx="10972800" cy="347472"/>
+          </a:xfrm>
+          <a:prstGeom prst="rect">
+            <a:avLst/>
+          </a:prstGeom>
+          <a:noFill/>
+        </p:spPr>
+        <p:txBody>
+          <a:bodyPr wrap="square">
+            <a:spAutoFit/>
+          </a:bodyPr>
+          <a:lstStyle/>
+          <a:p>
+            <a:pPr algn="l"/>
+            <a:r>
+              <a:rPr sz="1500" b="1" i="0">
+                <a:solidFill>
+                  <a:srgbClr val="1B2A4A"/>
+                </a:solidFill>
+                <a:latin typeface="Calibri"/>
+              </a:rPr>
+              <a:t>O LLM interpreta a missão (negação, falha, papéis: 100%); o cálculo de caminho otimiza.</a:t>
+            </a:r>
+          </a:p>
+        </p:txBody>
+      </p:sp>
+      <p:sp>
+        <p:nvSpPr>
+          <p:cNvPr id="55" name="TextBox 54"/>
+          <p:cNvSpPr txBox="1"/>
+          <p:nvPr/>
+        </p:nvSpPr>
+        <p:spPr>
+          <a:xfrm>
+            <a:off x="685800" y="5157216"/>
+            <a:ext cx="10972800" cy="411480"/>
+          </a:xfrm>
+          <a:prstGeom prst="rect">
+            <a:avLst/>
+          </a:prstGeom>
+          <a:noFill/>
+        </p:spPr>
+        <p:txBody>
+          <a:bodyPr wrap="square">
+            <a:spAutoFit/>
+          </a:bodyPr>
+          <a:lstStyle/>
+          <a:p>
+            <a:pPr algn="l"/>
+            <a:r>
+              <a:rPr sz="1300" b="0" i="0">
+                <a:solidFill>
+                  <a:srgbClr val="6B7280"/>
+                </a:solidFill>
+                <a:latin typeface="Calibri"/>
+              </a:rPr>
+              <a:t>Piloto: só a decisão, sem execução no Gazebo · 1 ambiente · 5–10 repetições por missão</a:t>
+            </a:r>
+          </a:p>
+        </p:txBody>
+      </p:sp>
+      <p:sp>
+        <p:nvSpPr>
+          <p:cNvPr id="100" name="Badge Achado Novo"/>
+          <p:cNvSpPr/>
+          <p:nvPr/>
+        </p:nvSpPr>
+        <p:spPr>
+          <a:xfrm>
+            <a:off x="10050000" y="320040"/>
+            <a:ext cx="1828800" cy="457200"/>
+          </a:xfrm>
+          <a:prstGeom prst="roundRect">
+            <a:avLst>
+              <a:gd name="adj" fmla="val 50000"/>
+            </a:avLst>
+          </a:prstGeom>
+          <a:solidFill>
+            <a:srgbClr val="F59E0B"/>
+          </a:solidFill>
+          <a:ln>
+            <a:noFill/>
+          </a:ln>
+        </p:spPr>
+        <p:style>
+          <a:lnRef idx="1">
+            <a:schemeClr val="accent1"/>
+          </a:lnRef>
+          <a:fillRef idx="3">
+            <a:schemeClr val="accent1"/>
+          </a:fillRef>
+          <a:effectRef idx="2">
+            <a:schemeClr val="accent1"/>
+          </a:effectRef>
+          <a:fontRef idx="minor">
+            <a:schemeClr val="lt1"/>
+          </a:fontRef>
+        </p:style>
+        <p:txBody>
+          <a:bodyPr rtlCol="0" anchor="ctr"/>
+          <a:lstStyle/>
+          <a:p>
+            <a:pPr algn="ctr"/>
+            <a:r>
+              <a:rPr sz="1300" b="1" i="0">
+                <a:solidFill>
+                  <a:srgbClr val="1B2A4A"/>
+                </a:solidFill>
+                <a:latin typeface="Calibri"/>
+              </a:rPr>
+              <a:t>● ACHADO NOVO</a:t>
+            </a:r>
+          </a:p>
+        </p:txBody>
+      </p:sp>
+    </p:spTree>
+  </p:cSld>
+  <p:clrMapOvr>
+    <a:masterClrMapping/>
+  </p:clrMapOvr>
+</p:sld>
+</file>
+
 <file path=ppt/slides/slide2.xml><?xml version="1.0" encoding="utf-8"?>
 <p:sld xmlns:a="http://schemas.openxmlformats.org/drawingml/2006/main" xmlns:r="http://schemas.openxmlformats.org/officeDocument/2006/relationships" xmlns:p="http://schemas.openxmlformats.org/presentationml/2006/main">
   <p:cSld>
@@ -15288,7 +17491,7 @@
                 </a:solidFill>
                 <a:latin typeface="Calibri"/>
               </a:rPr>
-              <a:t>06.  Resultados, hipóteses e piloto FUUT</a:t>
+              <a:t>06.  Resultados, hipóteses e pilotos (FUUT e missão)</a:t>
             </a:r>
           </a:p>
         </p:txBody>

</xml_diff>

<commit_message>
Defesa: slide 14 e fala registram reprodução em máquina diferente (Ubuntu)
Testei hoje o estudo de alocação de missão (windows-version) nesta
máquina Ubuntu: os baselines determinísticos (fixed/greedy/optimal)
bateram exatamente com os números já no slide (42%/106% pior caso), e
a parte com LLM reproduziu o mesmo padrão, embora só parcialmente
(crédito de API esgotou no meio da campanha "difícil"). Acrescenta
uma linha curta no slide "Piloto de Missão — LLM vs. Ótimo" e duas
frases na fala, reforçando reprodutibilidade — o tema central da
dissertação — com evidência de hoje, não só a campanha original.

Validado (zero erros) e revisado visualmente (render em alta
resolução do slide editado + grade de todos os 19 slides).

Co-Authored-By: Claude Sonnet 5 <noreply@anthropic.com>
</commit_message>
<xml_diff>
--- a/disserta-apresenta/apresentacao_defesa.pptx
+++ b/disserta-apresenta/apresentacao_defesa.pptx
@@ -5117,6 +5117,44 @@
             </a:r>
             <a:endParaRPr lang="en-US" sz="1300" dirty="0"/>
           </a:p>
+          <a:p>
+            <a:pPr marL="342900" indent="-342900">
+              <a:spcAft>
+                <a:spcPts val="1000"/>
+              </a:spcAft>
+              <a:buSzPct val="100000"/>
+              <a:buChar char="●"/>
+            </a:pPr>
+            <a:r>
+              <a:rPr lang="en-US" sz="1100" b="1" dirty="0">
+                <a:solidFill>
+                  <a:srgbClr val="333333"/>
+                </a:solidFill>
+                <a:latin typeface="Arial" pitchFamily="34" charset="0"/>
+                <a:ea typeface="Arial" pitchFamily="34" charset="-122"/>
+                <a:cs typeface="Arial" pitchFamily="34" charset="-120"/>
+              </a:rPr>
+              <a:t>Reproduzido: </a:t>
+            </a:r>
+            <a:pPr indent="0" marL="0">
+              <a:spcAft>
+                <a:spcPts val="1000"/>
+              </a:spcAft>
+              <a:buNone/>
+            </a:pPr>
+            <a:r>
+              <a:rPr lang="en-US" sz="1100" i="1" dirty="0">
+                <a:solidFill>
+                  <a:srgbClr val="333333"/>
+                </a:solidFill>
+                <a:latin typeface="Arial" pitchFamily="34" charset="0"/>
+                <a:ea typeface="Arial" pitchFamily="34" charset="-122"/>
+                <a:cs typeface="Arial" pitchFamily="34" charset="-120"/>
+              </a:rPr>
+              <a:t>baselines idênticos em outra máquina (Ubuntu); LLM parcialmente reconfirmado.</a:t>
+            </a:r>
+            <a:endParaRPr lang="en-US" sz="1100" dirty="0"/>
+          </a:p>
         </p:txBody>
       </p:sp>
       <p:pic>

</xml_diff>

<commit_message>
Defesa: volta a 19 slides, dobra "Relevância" pro slide de Conclusão
Autor pediu deck menor. O slide 18 dedicado ("Relevância — Confirmada
pela Literatura de 2025") saiu; seu argumento virou 1 bullet novo
("✓ Relevância:") dentro de "Trabalho Futuro e Conclusão", que já tinha
espaço sobrando. Removido via sldIdLst + clean.py (órfãos realmente
apagados, não só desreferenciados). Fala dobrada do mesmo jeito, slide
final "Obrigado" volta a ser o 19.

Avaliado se valia adicionar imagem nesse slide: não — já ficou denso
(6 bullets + 2 linhas), estouraria. O resto do deck já tem gráfico,
diagrama e ícones; esse é o resumo numérico final, que é esperado ser
mais denso em texto.

Validado (zero erros), renderizado e conferido programaticamente contra
o <p:sldIdLst> do pptx.

Co-Authored-By: Claude Sonnet 5 <noreply@anthropic.com>
</commit_message>
<xml_diff>
--- a/disserta-apresenta/apresentacao_defesa.pptx
+++ b/disserta-apresenta/apresentacao_defesa.pptx
@@ -22,7 +22,6 @@
     <p:sldId id="268" r:id="rId14"/>
     <p:sldId id="269" r:id="rId15"/>
     <p:sldId id="270" r:id="rId16"/>
-    <p:sldId id="275" r:id="rId26"/>
     <p:sldId id="271" r:id="rId17"/>
     <p:sldId id="272" r:id="rId18"/>
   </p:sldIdLst>
@@ -4591,6 +4590,44 @@
             <a:r>
               <a:rPr lang="en-US" sz="1200" b="1" dirty="0">
                 <a:solidFill>
+                  <a:srgbClr val="333333"/>
+                </a:solidFill>
+                <a:latin typeface="Arial" pitchFamily="34" charset="0"/>
+                <a:ea typeface="Arial" pitchFamily="34" charset="-122"/>
+                <a:cs typeface="Arial" pitchFamily="34" charset="-120"/>
+              </a:rPr>
+              <a:t>✓ Relevância: </a:t>
+            </a:r>
+            <a:pPr indent="0" marL="0">
+              <a:spcAft>
+                <a:spcPts val="1000"/>
+              </a:spcAft>
+              <a:buNone/>
+            </a:pPr>
+            <a:r>
+              <a:rPr lang="en-US" sz="1200" dirty="0">
+                <a:solidFill>
+                  <a:srgbClr val="333333"/>
+                </a:solidFill>
+                <a:latin typeface="Arial" pitchFamily="34" charset="0"/>
+                <a:ea typeface="Arial" pitchFamily="34" charset="-122"/>
+                <a:cs typeface="Arial" pitchFamily="34" charset="-120"/>
+              </a:rPr>
+              <a:t>nem teach-and-repeat, nem o TaskSLAM-Bench (2025), nem o laboratório virtual de Alt et al. (2025) medem repetibilidade do replanejamento global em navegação — a pergunta que este framework responde segue em aberto na literatura.</a:t>
+            </a:r>
+            <a:endParaRPr lang="en-US" sz="1200" dirty="0"/>
+          </a:p>
+          <a:p>
+            <a:pPr marL="342900" indent="-342900">
+              <a:spcAft>
+                <a:spcPts val="1000"/>
+              </a:spcAft>
+              <a:buSzPct val="100000"/>
+              <a:buChar char="●"/>
+            </a:pPr>
+            <a:r>
+              <a:rPr lang="en-US" sz="1200" b="1" dirty="0">
+                <a:solidFill>
                   <a:srgbClr val="DB1E2F"/>
                 </a:solidFill>
                 <a:latin typeface="Arial" pitchFamily="34" charset="0"/>
@@ -5709,299 +5746,6 @@
                 <a:cs typeface="Arial" pitchFamily="34" charset="-120"/>
               </a:rPr>
               <a:t>09. Trabalho futuro e conclusão</a:t>
-            </a:r>
-            <a:endParaRPr lang="en-US" sz="1300" dirty="0"/>
-          </a:p>
-        </p:txBody>
-      </p:sp>
-    </p:spTree>
-  </p:cSld>
-  <p:clrMapOvr>
-    <a:masterClrMapping/>
-  </p:clrMapOvr>
-</p:sld>
-</file>
-
-<file path=ppt/slides/slide20.xml><?xml version="1.0" encoding="utf-8"?>
-<p:sld xmlns:a="http://schemas.openxmlformats.org/drawingml/2006/main" xmlns:r="http://schemas.openxmlformats.org/officeDocument/2006/relationships" xmlns:p="http://schemas.openxmlformats.org/presentationml/2006/main">
-  <p:cSld name="Slide 13">
-    <p:bg>
-      <p:bgPr>
-        <a:solidFill>
-          <a:srgbClr val="FFFFFF"/>
-        </a:solidFill>
-      </p:bgPr>
-    </p:bg>
-    <p:spTree>
-      <p:nvGrpSpPr>
-        <p:cNvPr id="1" name=""/>
-        <p:cNvGrpSpPr/>
-        <p:nvPr/>
-      </p:nvGrpSpPr>
-      <p:grpSpPr>
-        <a:xfrm>
-          <a:off x="0" y="0"/>
-          <a:ext cx="0" cy="0"/>
-          <a:chOff x="0" y="0"/>
-          <a:chExt cx="0" cy="0"/>
-        </a:xfrm>
-      </p:grpSpPr>
-      <p:pic>
-        <p:nvPicPr>
-          <p:cNvPr id="2" name="Image 0" descr="/tmp/cbsoft_build/assets/logo_cin_ufpe.png">    </p:cNvPr>
-          <p:cNvPicPr>
-            <a:picLocks noChangeAspect="1"/>
-          </p:cNvPicPr>
-          <p:nvPr/>
-        </p:nvPicPr>
-        <p:blipFill>
-          <a:blip r:embed="rId1"/>
-          <a:stretch>
-            <a:fillRect/>
-          </a:stretch>
-        </p:blipFill>
-        <p:spPr>
-          <a:xfrm>
-            <a:off x="7223760" y="73152"/>
-            <a:ext cx="1828800" cy="539496"/>
-          </a:xfrm>
-          <a:prstGeom prst="rect">
-            <a:avLst/>
-          </a:prstGeom>
-        </p:spPr>
-      </p:pic>
-      <p:pic>
-        <p:nvPicPr>
-          <p:cNvPr id="3" name="Image 1" descr="/tmp/cbsoft_build/assets/logo_cinufpebr.png">    </p:cNvPr>
-          <p:cNvPicPr>
-            <a:picLocks noChangeAspect="1"/>
-          </p:cNvPicPr>
-          <p:nvPr/>
-        </p:nvPicPr>
-        <p:blipFill>
-          <a:blip r:embed="rId2"/>
-          <a:stretch>
-            <a:fillRect/>
-          </a:stretch>
-        </p:blipFill>
-        <p:spPr>
-          <a:xfrm>
-            <a:off x="7571232" y="4759452"/>
-            <a:ext cx="1481328" cy="310896"/>
-          </a:xfrm>
-          <a:prstGeom prst="rect">
-            <a:avLst/>
-          </a:prstGeom>
-        </p:spPr>
-      </p:pic>
-      <p:sp>
-        <p:nvSpPr>
-          <p:cNvPr id="4" name="Text 0"/>
-          <p:cNvSpPr txBox="1"/>
-          <p:nvPr/>
-        </p:nvSpPr>
-        <p:spPr>
-          <a:xfrm>
-            <a:off x="320040" y="384048"/>
-            <a:ext cx="6949440" cy="548640"/>
-          </a:xfrm>
-          <a:prstGeom prst="rect">
-            <a:avLst/>
-          </a:prstGeom>
-          <a:noFill/>
-          <a:ln/>
-        </p:spPr>
-        <p:txBody>
-          <a:bodyPr wrap="square" lIns="0" tIns="0" rIns="0" bIns="0" rtlCol="0" anchor="ctr"/>
-          <a:lstStyle/>
-          <a:p>
-            <a:pPr indent="0" marL="0">
-              <a:buNone/>
-            </a:pPr>
-            <a:r>
-              <a:rPr lang="en-US" sz="2600" dirty="0">
-                <a:solidFill>
-                  <a:srgbClr val="000000"/>
-                </a:solidFill>
-                <a:latin typeface="Arial" pitchFamily="34" charset="0"/>
-                <a:ea typeface="Arial" pitchFamily="34" charset="-122"/>
-                <a:cs typeface="Arial" pitchFamily="34" charset="-120"/>
-              </a:rPr>
-              <a:t>Relevância — Confirmada pela Literatura de 2025</a:t>
-            </a:r>
-            <a:endParaRPr lang="en-US" sz="2600" dirty="0"/>
-          </a:p>
-        </p:txBody>
-      </p:sp>
-      <p:sp>
-        <p:nvSpPr>
-          <p:cNvPr id="5" name="Text 1"/>
-          <p:cNvSpPr txBox="1"/>
-          <p:nvPr/>
-        </p:nvSpPr>
-        <p:spPr>
-          <a:xfrm>
-            <a:off x="320040" y="1143000"/>
-            <a:ext cx="8138160" cy="3474720"/>
-          </a:xfrm>
-          <a:prstGeom prst="rect">
-            <a:avLst/>
-          </a:prstGeom>
-          <a:noFill/>
-          <a:ln/>
-        </p:spPr>
-        <p:txBody>
-          <a:bodyPr wrap="square" lIns="0" tIns="0" rIns="0" bIns="0" rtlCol="0" anchor="t"/>
-          <a:lstStyle/>
-          <a:p>
-            <a:pPr marL="342900" indent="-342900">
-              <a:spcAft>
-                <a:spcPts val="1000"/>
-              </a:spcAft>
-              <a:buSzPct val="100000"/>
-              <a:buChar char="●"/>
-            </a:pPr>
-            <a:r>
-              <a:rPr lang="en-US" sz="1300" b="1" dirty="0">
-                <a:solidFill>
-                  <a:srgbClr val="333333"/>
-                </a:solidFill>
-                <a:latin typeface="Arial" pitchFamily="34" charset="0"/>
-                <a:ea typeface="Arial" pitchFamily="34" charset="-122"/>
-                <a:cs typeface="Arial" pitchFamily="34" charset="-120"/>
-              </a:rPr>
-              <a:t>Teach-and-repeat (clássico): </a:t>
-            </a:r>
-            <a:pPr indent="0" marL="0">
-              <a:spcAft>
-                <a:spcPts val="1000"/>
-              </a:spcAft>
-              <a:buNone/>
-            </a:pPr>
-            <a:r>
-              <a:rPr lang="en-US" sz="1300" dirty="0">
-                <a:solidFill>
-                  <a:srgbClr val="333333"/>
-                </a:solidFill>
-                <a:latin typeface="Arial" pitchFamily="34" charset="0"/>
-                <a:ea typeface="Arial" pitchFamily="34" charset="-122"/>
-                <a:cs typeface="Arial" pitchFamily="34" charset="-120"/>
-              </a:rPr>
-              <a:t>mede se o planejamento global se repete, sem correção local contra a rota ensinada — pergunta diferente da deles, ainda em aberto.</a:t>
-            </a:r>
-            <a:endParaRPr lang="en-US" sz="1300" dirty="0"/>
-          </a:p>
-          <a:p>
-            <a:pPr marL="342900" indent="-342900">
-              <a:spcAft>
-                <a:spcPts val="1000"/>
-              </a:spcAft>
-              <a:buSzPct val="100000"/>
-              <a:buChar char="●"/>
-            </a:pPr>
-            <a:r>
-              <a:rPr lang="en-US" sz="1300" b="1" dirty="0">
-                <a:solidFill>
-                  <a:srgbClr val="333333"/>
-                </a:solidFill>
-                <a:latin typeface="Arial" pitchFamily="34" charset="0"/>
-                <a:ea typeface="Arial" pitchFamily="34" charset="-122"/>
-                <a:cs typeface="Arial" pitchFamily="34" charset="-120"/>
-              </a:rPr>
-              <a:t>TaskSLAM-Bench (Georgia Tech, 2025): </a:t>
-            </a:r>
-            <a:pPr indent="0" marL="0">
-              <a:spcAft>
-                <a:spcPts val="1000"/>
-              </a:spcAft>
-              <a:buNone/>
-            </a:pPr>
-            <a:r>
-              <a:rPr lang="en-US" sz="1300" dirty="0">
-                <a:solidFill>
-                  <a:srgbClr val="333333"/>
-                </a:solidFill>
-                <a:latin typeface="Arial" pitchFamily="34" charset="0"/>
-                <a:ea typeface="Arial" pitchFamily="34" charset="-122"/>
-                <a:cs typeface="Arial" pitchFamily="34" charset="-120"/>
-              </a:rPr>
-              <a:t>chegou, de forma independente, ao mesmo diagnóstico desta dissertação — meses atrás, não há uma década.</a:t>
-            </a:r>
-            <a:endParaRPr lang="en-US" sz="1300" dirty="0"/>
-          </a:p>
-          <a:p>
-            <a:pPr marL="342900" indent="-342900">
-              <a:spcAft>
-                <a:spcPts val="1000"/>
-              </a:spcAft>
-              <a:buSzPct val="100000"/>
-              <a:buChar char="●"/>
-            </a:pPr>
-            <a:r>
-              <a:rPr lang="en-US" sz="1300" b="1" dirty="0">
-                <a:solidFill>
-                  <a:srgbClr val="333333"/>
-                </a:solidFill>
-                <a:latin typeface="Arial" pitchFamily="34" charset="0"/>
-                <a:ea typeface="Arial" pitchFamily="34" charset="-122"/>
-                <a:cs typeface="Arial" pitchFamily="34" charset="-120"/>
-              </a:rPr>
-              <a:t>Infraestrutura mais ambiciosa do campo (Alt et al., 2025): </a:t>
-            </a:r>
-            <a:pPr indent="0" marL="0">
-              <a:spcAft>
-                <a:spcPts val="1000"/>
-              </a:spcAft>
-              <a:buNone/>
-            </a:pPr>
-            <a:r>
-              <a:rPr lang="en-US" sz="1300" dirty="0">
-                <a:solidFill>
-                  <a:srgbClr val="333333"/>
-                </a:solidFill>
-                <a:latin typeface="Arial" pitchFamily="34" charset="0"/>
-                <a:ea typeface="Arial" pitchFamily="34" charset="-122"/>
-                <a:cs typeface="Arial" pitchFamily="34" charset="-120"/>
-              </a:rPr>
-              <a:t>laboratório virtual na nuvem + rastreamento de crenças do robô, mas nenhum número de repetibilidade em navegação — exemplos só de manipulação.</a:t>
-            </a:r>
-            <a:endParaRPr lang="en-US" sz="1300" dirty="0"/>
-          </a:p>
-          <a:p>
-            <a:pPr marL="342900" indent="-342900">
-              <a:spcAft>
-                <a:spcPts val="1000"/>
-              </a:spcAft>
-              <a:buSzPct val="100000"/>
-              <a:buChar char="●"/>
-            </a:pPr>
-            <a:r>
-              <a:rPr lang="en-US" sz="1300" b="1" dirty="0">
-                <a:solidFill>
-                  <a:srgbClr val="DB1E2F"/>
-                </a:solidFill>
-                <a:latin typeface="Arial" pitchFamily="34" charset="0"/>
-                <a:ea typeface="Arial" pitchFamily="34" charset="-122"/>
-                <a:cs typeface="Arial" pitchFamily="34" charset="-120"/>
-              </a:rPr>
-              <a:t>→ Conclusão: </a:t>
-            </a:r>
-            <a:pPr indent="0" marL="0">
-              <a:spcAft>
-                <a:spcPts val="1000"/>
-              </a:spcAft>
-              <a:buNone/>
-            </a:pPr>
-            <a:r>
-              <a:rPr lang="en-US" sz="1300" dirty="0">
-                <a:solidFill>
-                  <a:srgbClr val="333333"/>
-                </a:solidFill>
-                <a:latin typeface="Arial" pitchFamily="34" charset="0"/>
-                <a:ea typeface="Arial" pitchFamily="34" charset="-122"/>
-                <a:cs typeface="Arial" pitchFamily="34" charset="-120"/>
-              </a:rPr>
-              <a:t>a pergunta que este framework responde segue sem resposta em qualquer um dos trabalhos revisados.</a:t>
             </a:r>
             <a:endParaRPr lang="en-US" sz="1300" dirty="0"/>
           </a:p>

</xml_diff>

<commit_message>
Defesa: adiciona print real da interface web ao slide 5
Primeiro print de tela do Fleet UI no deck inteiro — até agora "Interface
web" era só texto. Print real (Playwright contra o frontend atual,
branch mission-coordinate-large-scale), recortado pra mostrar só o mapa
com os 2 robôs navegando (tb1 verde, tb2 laranja) e os waypoints — o
resto da tela (sidebar, output) ficaria ilegível no tamanho do slide.
Dados de pose são simulados via mock de API, não uma execução real no
Gazebo; a renderização em si (canvas, marcadores, toolbar) é 100% código
real rodando.

Caixa de texto encolhida pra layout de 2 colunas (mesmo padrão do slide
11). Fala do slide 5 ganhou 1 frase apontando a imagem.

Validado (zero erros) e revisado visualmente.

Co-Authored-By: Claude Sonnet 5 <noreply@anthropic.com>
</commit_message>
<xml_diff>
--- a/disserta-apresenta/apresentacao_defesa.pptx
+++ b/disserta-apresenta/apresentacao_defesa.pptx
@@ -6443,7 +6443,7 @@
         <p:spPr>
           <a:xfrm>
             <a:off x="320040" y="1143000"/>
-            <a:ext cx="8138160" cy="3474720"/>
+            <a:ext cx="4700000" cy="3474720"/>
           </a:xfrm>
           <a:prstGeom prst="rect">
             <a:avLst/>
@@ -6684,6 +6684,35 @@
           </a:p>
         </p:txBody>
       </p:sp>
+      <p:pic>
+        <p:nvPicPr>
+          <p:cNvPr id="6" name="Image 2" descr="print real da interface web"/>
+          <p:cNvPicPr>
+            <a:picLocks noChangeAspect="1"/>
+          </p:cNvPicPr>
+          <p:nvPr/>
+        </p:nvPicPr>
+        <p:blipFill>
+          <a:blip r:embed="rId5"/>
+          <a:stretch>
+            <a:fillRect/>
+          </a:stretch>
+        </p:blipFill>
+        <p:spPr>
+          <a:xfrm>
+            <a:off x="5250000" y="1300000"/>
+            <a:ext cx="3350000" cy="3200000"/>
+          </a:xfrm>
+          <a:prstGeom prst="rect">
+            <a:avLst/>
+          </a:prstGeom>
+          <a:ln w="9525">
+            <a:solidFill>
+              <a:srgbClr val="2A2A2A"/>
+            </a:solidFill>
+          </a:ln>
+        </p:spPr>
+      </p:pic>
     </p:spTree>
   </p:cSld>
   <p:clrMapOvr>

</xml_diff>